<commit_message>
Recordings slides removed; Drive links out of three old decks
Laura (2026-10-18): drop the per-chapter recordings slides and the README's
mention of the old class recordings (the videos will be remade); keep
chapter 0.1's list and Nick Battista's IB2d videos; take the 2020 course
folder's link and its two sample-data links out of the old decks.

- Chapters 7, 8a, 8b, 9a, 9b, 10-17, 19-25: the recordings slide removed;
  the non-recording facts said nowhere else moved into References
  (8b, 10, 20, 21).
- Chapters 18, 26, 28, 33: the slide keeps its links or screenshot notes
  (and Shannon Jones's third-party videos); chapter 26 uses the 2020
  deck's own title.
- Appendix C regenerated: IBFE/10.1 now carries the README's restart
  warning.
- README: the Videos paragraph; the originals/ row.
- originals/: five links replaced by "[link removed]" in three decks;
  the job-script links stay.

Fact-checked.

Co-Authored-By: Claude Opus 5.5 <noreply@anthropic.com>
</commit_message>
<xml_diff>
--- a/originals/Data Visualizationand Analysis/Lecture 1 - VISIT - How to plot IBAMR Data.pptx
+++ b/originals/Data Visualizationand Analysis/Lecture 1 - VISIT - How to plot IBAMR Data.pptx
@@ -10841,16 +10841,8 @@
           <a:lstStyle/>
           <a:p>
             <a:r>
-              <a:rPr lang="en-US" sz="2400" dirty="0">
-                <a:hlinkClick r:id="rId2"/>
-              </a:rPr>
-              <a:t>https://</a:t>
-            </a:r>
-            <a:r>
-              <a:rPr lang="en-US" sz="2400" dirty="0" smtClean="0">
-                <a:hlinkClick r:id="rId2"/>
-              </a:rPr>
-              <a:t>drive.google.com/open?id=1thvMjhnjRB5gNtvCPoCX8T85-UShohyl</a:t>
+              <a:rPr lang="en-US" sz="2400" dirty="0"/>
+              <a:t>[link removed]</a:t>
             </a:r>
             <a:endParaRPr lang="en-US" sz="2400" dirty="0" smtClean="0"/>
           </a:p>

</xml_diff>